<commit_message>
Level 5 Lesson 11 draft listening audio (2:02)
</commit_message>
<xml_diff>
--- a/level5/slides/Level5_Lesson11_Slides.pptx
+++ b/level5/slides/Level5_Lesson11_Slides.pptx
@@ -8,32 +8,32 @@
     <p:notesMasterId r:id="rId22"/>
   </p:notesMasterIdLst>
   <p:sldIdLst>
-    <p:sldId id="939" r:id="rId33"/>
-    <p:sldId id="940" r:id="rId34"/>
-    <p:sldId id="941" r:id="rId35"/>
-    <p:sldId id="942" r:id="rId36"/>
-    <p:sldId id="943" r:id="rId31"/>
-    <p:sldId id="944" r:id="rId30"/>
-    <p:sldId id="945" r:id="rId29"/>
-    <p:sldId id="946" r:id="rId28"/>
-    <p:sldId id="947" r:id="rId27"/>
-    <p:sldId id="948" r:id="rId20"/>
-    <p:sldId id="949" r:id="rId18"/>
-    <p:sldId id="950" r:id="rId17"/>
-    <p:sldId id="951" r:id="rId16"/>
-    <p:sldId id="952" r:id="rId14"/>
-    <p:sldId id="953" r:id="rId13"/>
-    <p:sldId id="954" r:id="rId12"/>
-    <p:sldId id="955" r:id="rId11"/>
-    <p:sldId id="956" r:id="rId10"/>
-    <p:sldId id="957" r:id="rId8"/>
-    <p:sldId id="958" r:id="rId7"/>
-    <p:sldId id="959" r:id="rId6"/>
-    <p:sldId id="960" r:id="rId5"/>
-    <p:sldId id="961" r:id="rId4"/>
-    <p:sldId id="962" r:id="rId3"/>
-    <p:sldId id="963" r:id="rId57"/>
-    <p:sldId id="964" r:id="rId2"/>
+    <p:sldId id="1069" r:id="rId32"/>
+    <p:sldId id="1070" r:id="rId21"/>
+    <p:sldId id="1071" r:id="rId19"/>
+    <p:sldId id="1072" r:id="rId15"/>
+    <p:sldId id="1073" r:id="rId37"/>
+    <p:sldId id="1074" r:id="rId38"/>
+    <p:sldId id="1075" r:id="rId39"/>
+    <p:sldId id="1076" r:id="rId40"/>
+    <p:sldId id="1077" r:id="rId41"/>
+    <p:sldId id="1078" r:id="rId42"/>
+    <p:sldId id="1079" r:id="rId43"/>
+    <p:sldId id="1080" r:id="rId44"/>
+    <p:sldId id="1081" r:id="rId45"/>
+    <p:sldId id="1082" r:id="rId46"/>
+    <p:sldId id="1083" r:id="rId47"/>
+    <p:sldId id="1084" r:id="rId48"/>
+    <p:sldId id="1085" r:id="rId49"/>
+    <p:sldId id="1086" r:id="rId50"/>
+    <p:sldId id="1087" r:id="rId51"/>
+    <p:sldId id="1088" r:id="rId52"/>
+    <p:sldId id="1089" r:id="rId53"/>
+    <p:sldId id="1090" r:id="rId54"/>
+    <p:sldId id="1091" r:id="rId55"/>
+    <p:sldId id="1092" r:id="rId56"/>
+    <p:sldId id="1093" r:id="rId9"/>
+    <p:sldId id="1094" r:id="rId58"/>
   </p:sldIdLst>
   <p:sldSz cx="12192000" cy="6858000"/>
   <p:notesSz cx="6858000" cy="12192000"/>
@@ -481,7 +481,7 @@
 </p:notesMaster>
 </file>
 
-<file path=ppt/notesSlides/notesSlide1.xml><?xml version="1.0" encoding="utf-8"?>
+<file path=ppt/notesSlides/notesSlide14.xml><?xml version="1.0" encoding="utf-8"?>
 <p:notes xmlns:a="http://schemas.openxmlformats.org/drawingml/2006/main" xmlns:p="http://schemas.openxmlformats.org/presentationml/2006/main" xmlns:r="http://schemas.openxmlformats.org/officeDocument/2006/relationships">
   <p:cSld>
     <p:spTree>
@@ -526,27 +526,17 @@
           <a:lstStyle/>
           <a:p>
             <a:r>
-              <a:t>Credits. You don't need to read this slide in class.</a:t>
-            </a:r>
-          </a:p>
-          <a:p>
-            <a:r>
-              <a:t>Pictures: Twemoji graphics by Twitter, Inc. and other contributors, CC BY 4.0; the file-by-file list is in images/CREDITS.md.</a:t>
-            </a:r>
-          </a:p>
-          <a:p>
-            <a:r>
-              <a:t>Audio: the listening audio for this lesson (about 2:30) is coming soon. It will use computer-generated voices (Chatterbox TTS cloned from synthetic Kokoro-82M reference clips); no recordings of real people. Until it is ready, read the listening script (in the notes of the Before You Listen slide) with a volunteer. The names and the story are invented.</a:t>
-            </a:r>
-          </a:p>
-          <a:p>
-            <a:r>
-              <a:t>Course materials: © 2026 the authors, licensed under CC BY-NC-SA 4.0 (https://creativecommons.org/licenses/by-nc-sa/4.0/).</a:t>
-            </a:r>
-          </a:p>
-          <a:p>
-            <a:r>
-              <a:t>Lesson plan: Picture Credits. Picture list: images/CREDITS.md.</a:t>
+              <a:t>Each click shows the next card.</a:t>
+            </a:r>
+          </a:p>
+          <a:p>
+            <a:r>
+              <a:t>A asks. B answers. Then switch.</a:t>
+            </a:r>
+          </a:p>
+          <a:p>
+            <a:r>
+              <a:t>Lesson plan: Step 1; Opening Talk page.</a:t>
             </a:r>
           </a:p>
         </p:txBody>
@@ -571,7 +561,7 @@
 </p:notes>
 </file>
 
-<file path=ppt/notesSlides/notesSlide10.xml><?xml version="1.0" encoding="utf-8"?>
+<file path=ppt/notesSlides/notesSlide18.xml><?xml version="1.0" encoding="utf-8"?>
 <p:notes xmlns:a="http://schemas.openxmlformats.org/drawingml/2006/main" xmlns:p="http://schemas.openxmlformats.org/presentationml/2006/main" xmlns:r="http://schemas.openxmlformats.org/officeDocument/2006/relationships">
   <p:cSld>
     <p:spTree>
@@ -616,12 +606,22 @@
           <a:lstStyle/>
           <a:p>
             <a:r>
-              <a:t>Click to show each answer: 1 is • 2 attached • 3 takes • 4 could • 5 received • 6 helps</a:t>
-            </a:r>
-          </a:p>
-          <a:p>
-            <a:r>
-              <a:t>Lesson plan: Step 4; Grammar Practice A; Answer key.</a:t>
+              <a:t>Step 1 · 6:00–6:06 · Opening Talk.</a:t>
+            </a:r>
+          </a:p>
+          <a:p>
+            <a:r>
+              <a:t>Work with a partner.</a:t>
+            </a:r>
+          </a:p>
+          <a:p>
+            <a:r>
+              <a:t>Lesson plan: Step 1; Opening Talk page.</a:t>
+            </a:r>
+          </a:p>
+          <a:p>
+            <a:r>
+              <a:t>Picture: Twemoji graphics by Twitter, Inc. and other contributors (https://github.com/jdecked/twemoji), CC BY 4.0 (https://creativecommons.org/licenses/by/4.0/); resized and combined, with signs and labels (images/CREDITS.md).</a:t>
             </a:r>
           </a:p>
         </p:txBody>
@@ -646,7 +646,7 @@
 </p:notes>
 </file>
 
-<file path=ppt/notesSlides/notesSlide11.xml><?xml version="1.0" encoding="utf-8"?>
+<file path=ppt/notesSlides/notesSlide20.xml><?xml version="1.0" encoding="utf-8"?>
 <p:notes xmlns:a="http://schemas.openxmlformats.org/drawingml/2006/main" xmlns:p="http://schemas.openxmlformats.org/presentationml/2006/main" xmlns:r="http://schemas.openxmlformats.org/officeDocument/2006/relationships">
   <p:cSld>
     <p:spTree>
@@ -691,17 +691,12 @@
           <a:lstStyle/>
           <a:p>
             <a:r>
-              <a:t>Grammar Box 4: have to. Each click shows the answer side.</a:t>
-            </a:r>
-          </a:p>
-          <a:p>
-            <a:r>
-              <a:t>Lesson plan: Step 4; Grammar Box 4.</a:t>
-            </a:r>
-          </a:p>
-          <a:p>
-            <a:r>
-              <a:t>Picture: Twemoji graphics by Twitter, Inc. and other contributors (https://github.com/jdecked/twemoji), CC BY 4.0 (https://creativecommons.org/licenses/by/4.0/); resized and combined, with signs and labels (images/CREDITS.md).</a:t>
+              <a:t>Read each goal slowly. Learners repeat.</a:t>
+            </a:r>
+          </a:p>
+          <a:p>
+            <a:r>
+              <a:t>Lesson plan: At a glance: Objectives.</a:t>
             </a:r>
           </a:p>
         </p:txBody>
@@ -726,7 +721,7 @@
 </p:notes>
 </file>
 
-<file path=ppt/notesSlides/notesSlide12.xml><?xml version="1.0" encoding="utf-8"?>
+<file path=ppt/notesSlides/notesSlide26.xml><?xml version="1.0" encoding="utf-8"?>
 <p:notes xmlns:a="http://schemas.openxmlformats.org/drawingml/2006/main" xmlns:p="http://schemas.openxmlformats.org/presentationml/2006/main" xmlns:r="http://schemas.openxmlformats.org/officeDocument/2006/relationships">
   <p:cSld>
     <p:spTree>
@@ -771,12 +766,22 @@
           <a:lstStyle/>
           <a:p>
             <a:r>
-              <a:t>Grammar Box 3: what was sent. Each click shows the answer side.</a:t>
-            </a:r>
-          </a:p>
-          <a:p>
-            <a:r>
-              <a:t>Lesson plan: Step 4; Grammar Box 3.</a:t>
+              <a:t>Welcome learners as they arrive.</a:t>
+            </a:r>
+          </a:p>
+          <a:p>
+            <a:r>
+              <a:t>Read the three lines under Today you will.</a:t>
+            </a:r>
+          </a:p>
+          <a:p>
+            <a:r>
+              <a:t>It is not insurance advice.</a:t>
+            </a:r>
+          </a:p>
+          <a:p>
+            <a:r>
+              <a:t>Lesson plan: Topic; At a glance: Objectives.</a:t>
             </a:r>
           </a:p>
           <a:p>
@@ -806,7 +811,7 @@
 </p:notes>
 </file>
 
-<file path=ppt/notesSlides/notesSlide13.xml><?xml version="1.0" encoding="utf-8"?>
+<file path=ppt/notesSlides/notesSlide31.xml><?xml version="1.0" encoding="utf-8"?>
 <p:notes xmlns:a="http://schemas.openxmlformats.org/drawingml/2006/main" xmlns:p="http://schemas.openxmlformats.org/presentationml/2006/main" xmlns:r="http://schemas.openxmlformats.org/officeDocument/2006/relationships">
   <p:cSld>
     <p:spTree>
@@ -851,17 +856,22 @@
           <a:lstStyle/>
           <a:p>
             <a:r>
-              <a:t>Grammar Box 2: a soft request. Each click shows the answer side.</a:t>
-            </a:r>
-          </a:p>
-          <a:p>
-            <a:r>
-              <a:t>Lesson plan: Step 4; Grammar Box 2.</a:t>
-            </a:r>
-          </a:p>
-          <a:p>
-            <a:r>
-              <a:t>Picture: Twemoji graphics by Twitter, Inc. and other contributors (https://github.com/jdecked/twemoji), CC BY 4.0 (https://creativecommons.org/licenses/by/4.0/); resized and combined, with signs and labels (images/CREDITS.md).</a:t>
+              <a:t>Step 2 · 6:06–6:12 · New Words.</a:t>
+            </a:r>
+          </a:p>
+          <a:p>
+            <a:r>
+              <a:t>Point to each picture. Learners repeat. ★ = most important.</a:t>
+            </a:r>
+          </a:p>
+          <a:p>
+            <a:r>
+              <a:t>Lesson plan: Step 2; New Words page.</a:t>
+            </a:r>
+          </a:p>
+          <a:p>
+            <a:r>
+              <a:t>Pictures: Twemoji graphics by Twitter, Inc. and other contributors (https://github.com/jdecked/twemoji), CC BY 4.0 (https://creativecommons.org/licenses/by/4.0/); resized and combined, with signs and labels (images/CREDITS.md).</a:t>
             </a:r>
           </a:p>
         </p:txBody>
@@ -886,7 +896,7 @@
 </p:notes>
 </file>
 
-<file path=ppt/notesSlides/notesSlide15.xml><?xml version="1.0" encoding="utf-8"?>
+<file path=ppt/notesSlides/notesSlide32.xml><?xml version="1.0" encoding="utf-8"?>
 <p:notes xmlns:a="http://schemas.openxmlformats.org/drawingml/2006/main" xmlns:p="http://schemas.openxmlformats.org/presentationml/2006/main" xmlns:r="http://schemas.openxmlformats.org/officeDocument/2006/relationships">
   <p:cSld>
     <p:spTree>
@@ -931,17 +941,17 @@
           <a:lstStyle/>
           <a:p>
             <a:r>
-              <a:t>Grammar Box 1: a gerund is the subject. Each click shows the answer side.</a:t>
-            </a:r>
-          </a:p>
-          <a:p>
-            <a:r>
-              <a:t>Lesson plan: Step 4; Grammar Box 1.</a:t>
-            </a:r>
-          </a:p>
-          <a:p>
-            <a:r>
-              <a:t>Picture: Twemoji graphics by Twitter, Inc. and other contributors (https://github.com/jdecked/twemoji), CC BY 4.0 (https://creativecommons.org/licenses/by/4.0/); resized and combined, with signs and labels (images/CREDITS.md).</a:t>
+              <a:t>A points to a picture. B names it and uses it in one sentence. Then switch.</a:t>
+            </a:r>
+          </a:p>
+          <a:p>
+            <a:r>
+              <a:t>Lesson plan: Step 2; New Words page; Partner game.</a:t>
+            </a:r>
+          </a:p>
+          <a:p>
+            <a:r>
+              <a:t>Pictures: Twemoji graphics by Twitter, Inc. and other contributors (https://github.com/jdecked/twemoji), CC BY 4.0 (https://creativecommons.org/licenses/by/4.0/); resized and combined, with signs and labels (images/CREDITS.md).</a:t>
             </a:r>
           </a:p>
         </p:txBody>
@@ -966,7 +976,7 @@
 </p:notes>
 </file>
 
-<file path=ppt/notesSlides/notesSlide16.xml><?xml version="1.0" encoding="utf-8"?>
+<file path=ppt/notesSlides/notesSlide33.xml><?xml version="1.0" encoding="utf-8"?>
 <p:notes xmlns:a="http://schemas.openxmlformats.org/drawingml/2006/main" xmlns:p="http://schemas.openxmlformats.org/presentationml/2006/main" xmlns:r="http://schemas.openxmlformats.org/officeDocument/2006/relationships">
   <p:cSld>
     <p:spTree>
@@ -1011,12 +1021,32 @@
           <a:lstStyle/>
           <a:p>
             <a:r>
-              <a:t>gonna and wanna are short forms. This listening uses the full forms. Say each line two times.</a:t>
-            </a:r>
-          </a:p>
-          <a:p>
-            <a:r>
-              <a:t>Lesson plan: Step 3: Hear it, say it.</a:t>
+              <a:t>The answers are hidden. Ask, then click.</a:t>
+            </a:r>
+          </a:p>
+          <a:p>
+            <a:r>
+              <a:t>1. One.</a:t>
+            </a:r>
+          </a:p>
+          <a:p>
+            <a:r>
+              <a:t>2. *is*</a:t>
+            </a:r>
+          </a:p>
+          <a:p>
+            <a:r>
+              <a:t>3. It was attached.</a:t>
+            </a:r>
+          </a:p>
+          <a:p>
+            <a:r>
+              <a:t>Lesson plan: Step 2: Check the Meaning.</a:t>
+            </a:r>
+          </a:p>
+          <a:p>
+            <a:r>
+              <a:t>Pictures: Twemoji graphics by Twitter, Inc. and other contributors (https://github.com/jdecked/twemoji), CC BY 4.0 (https://creativecommons.org/licenses/by/4.0/); resized and combined, with signs and labels (images/CREDITS.md).</a:t>
             </a:r>
           </a:p>
         </p:txBody>
@@ -1041,7 +1071,7 @@
 </p:notes>
 </file>
 
-<file path=ppt/notesSlides/notesSlide17.xml><?xml version="1.0" encoding="utf-8"?>
+<file path=ppt/notesSlides/notesSlide34.xml><?xml version="1.0" encoding="utf-8"?>
 <p:notes xmlns:a="http://schemas.openxmlformats.org/drawingml/2006/main" xmlns:p="http://schemas.openxmlformats.org/presentationml/2006/main" xmlns:r="http://schemas.openxmlformats.org/officeDocument/2006/relationships">
   <p:cSld>
     <p:spTree>
@@ -1086,12 +1116,27 @@
           <a:lstStyle/>
           <a:p>
             <a:r>
-              <a:t>Click to show each answer: 1 Waiting • 2 was received • 3 was attached • 4 Filing • 5 Sending • 6 Sending</a:t>
-            </a:r>
-          </a:p>
-          <a:p>
-            <a:r>
-              <a:t>Lesson plan: Step 3; Listening Task C; Answer key.</a:t>
+              <a:t>Step 3 · 6:12–6:32 · Listening. Play 1 is Task A. Play 2 is Tasks B and C. A third play is fine.</a:t>
+            </a:r>
+          </a:p>
+          <a:p>
+            <a:r>
+              <a:t>Hector calls about a cracked-screen claim.</a:t>
+            </a:r>
+          </a:p>
+          <a:p>
+            <a:r>
+              <a:t>The script says going to and want to. Learners only need to recognize gonna and wanna.</a:t>
+            </a:r>
+          </a:p>
+          <a:p>
+            <a:r>
+              <a:t>Lesson plan: Step 3; Listening page.</a:t>
+            </a:r>
+          </a:p>
+          <a:p>
+            <a:r>
+              <a:t>Picture: Twemoji graphics by Twitter, Inc. and other contributors (https://github.com/jdecked/twemoji), CC BY 4.0 (https://creativecommons.org/licenses/by/4.0/); resized and combined, with signs and labels (images/CREDITS.md).</a:t>
             </a:r>
           </a:p>
         </p:txBody>
@@ -1116,7 +1161,7 @@
 </p:notes>
 </file>
 
-<file path=ppt/notesSlides/notesSlide19.xml><?xml version="1.0" encoding="utf-8"?>
+<file path=ppt/notesSlides/notesSlide35.xml><?xml version="1.0" encoding="utf-8"?>
 <p:notes xmlns:a="http://schemas.openxmlformats.org/drawingml/2006/main" xmlns:p="http://schemas.openxmlformats.org/presentationml/2006/main" xmlns:r="http://schemas.openxmlformats.org/officeDocument/2006/relationships">
   <p:cSld>
     <p:spTree>
@@ -1161,12 +1206,12 @@
           <a:lstStyle/>
           <a:p>
             <a:r>
-              <a:t>Click to circle each answer: 1 was received • 2 was attached • 3 the estimate • 4 seven one • 5 four two eight • 6 send it today</a:t>
-            </a:r>
-          </a:p>
-          <a:p>
-            <a:r>
-              <a:t>Lesson plan: Step 3; Listening Task B; Answer key.</a:t>
+              <a:t>Click to circle b.</a:t>
+            </a:r>
+          </a:p>
+          <a:p>
+            <a:r>
+              <a:t>Lesson plan: Step 3; Listening Task A; Answer key.</a:t>
             </a:r>
           </a:p>
         </p:txBody>
@@ -1191,7 +1236,7 @@
 </p:notes>
 </file>
 
-<file path=ppt/notesSlides/notesSlide2.xml><?xml version="1.0" encoding="utf-8"?>
+<file path=ppt/notesSlides/notesSlide36.xml><?xml version="1.0" encoding="utf-8"?>
 <p:notes xmlns:a="http://schemas.openxmlformats.org/drawingml/2006/main" xmlns:p="http://schemas.openxmlformats.org/presentationml/2006/main" xmlns:r="http://schemas.openxmlformats.org/officeDocument/2006/relationships">
   <p:cSld>
     <p:spTree>
@@ -1236,22 +1281,12 @@
           <a:lstStyle/>
           <a:p>
             <a:r>
-              <a:t>Step 7 · 7:25–7:30 · Exit ticket and homework. Never skip the exit ticket.</a:t>
-            </a:r>
-          </a:p>
-          <a:p>
-            <a:r>
-              <a:t>Start a claim letter.</a:t>
-            </a:r>
-          </a:p>
-          <a:p>
-            <a:r>
-              <a:t>Lesson plan: Step 7; Exit Ticket page; Homework page.</a:t>
-            </a:r>
-          </a:p>
-          <a:p>
-            <a:r>
-              <a:t>Picture: Twemoji graphics by Twitter, Inc. and other contributors (https://github.com/jdecked/twemoji), CC BY 4.0 (https://creativecommons.org/licenses/by/4.0/); resized and combined, with signs and labels (images/CREDITS.md).</a:t>
+              <a:t>Click to circle each answer: 1 was received • 2 was attached • 3 the estimate • 4 seven one • 5 four two eight • 6 send it today</a:t>
+            </a:r>
+          </a:p>
+          <a:p>
+            <a:r>
+              <a:t>Lesson plan: Step 3; Listening Task B; Answer key.</a:t>
             </a:r>
           </a:p>
         </p:txBody>
@@ -1276,7 +1311,7 @@
 </p:notes>
 </file>
 
-<file path=ppt/notesSlides/notesSlide21.xml><?xml version="1.0" encoding="utf-8"?>
+<file path=ppt/notesSlides/notesSlide37.xml><?xml version="1.0" encoding="utf-8"?>
 <p:notes xmlns:a="http://schemas.openxmlformats.org/drawingml/2006/main" xmlns:p="http://schemas.openxmlformats.org/presentationml/2006/main" xmlns:r="http://schemas.openxmlformats.org/officeDocument/2006/relationships">
   <p:cSld>
     <p:spTree>
@@ -1321,12 +1356,12 @@
           <a:lstStyle/>
           <a:p>
             <a:r>
-              <a:t>Click to circle b.</a:t>
-            </a:r>
-          </a:p>
-          <a:p>
-            <a:r>
-              <a:t>Lesson plan: Step 3; Listening Task A; Answer key.</a:t>
+              <a:t>Click to show each answer: 1 Waiting • 2 was received • 3 was attached • 4 Filing • 5 Sending • 6 Sending</a:t>
+            </a:r>
+          </a:p>
+          <a:p>
+            <a:r>
+              <a:t>Lesson plan: Step 3; Listening Task C; Answer key.</a:t>
             </a:r>
           </a:p>
         </p:txBody>
@@ -1351,7 +1386,7 @@
 </p:notes>
 </file>
 
-<file path=ppt/notesSlides/notesSlide22.xml><?xml version="1.0" encoding="utf-8"?>
+<file path=ppt/notesSlides/notesSlide38.xml><?xml version="1.0" encoding="utf-8"?>
 <p:notes xmlns:a="http://schemas.openxmlformats.org/drawingml/2006/main" xmlns:p="http://schemas.openxmlformats.org/presentationml/2006/main" xmlns:r="http://schemas.openxmlformats.org/officeDocument/2006/relationships">
   <p:cSld>
     <p:spTree>
@@ -1396,127 +1431,12 @@
           <a:lstStyle/>
           <a:p>
             <a:r>
-              <a:t>Step 3 · 6:12–6:32 · Listening. Play 1 is Task A. Play 2 is Tasks B and C. A third play is fine.</a:t>
-            </a:r>
-          </a:p>
-          <a:p>
-            <a:r>
-              <a:t>Hector calls about a cracked-screen claim.</a:t>
-            </a:r>
-          </a:p>
-          <a:p>
-            <a:r>
-              <a:t>The script says going to and want to. Learners only need to recognize gonna and wanna.</a:t>
-            </a:r>
-          </a:p>
-          <a:p>
-            <a:r>
-              <a:t>Lesson plan: Step 3; Listening page.</a:t>
-            </a:r>
-          </a:p>
-          <a:p>
-            <a:r>
-              <a:t>Picture: Twemoji graphics by Twitter, Inc. and other contributors (https://github.com/jdecked/twemoji), CC BY 4.0 (https://creativecommons.org/licenses/by/4.0/); resized and combined, with signs and labels (images/CREDITS.md).</a:t>
-            </a:r>
-          </a:p>
-          <a:p>
-            <a:r>
-              <a:t>Listening script (the audio is coming soon; until then, read it aloud with a volunteer at a normal, friendly speed):</a:t>
-            </a:r>
-          </a:p>
-          <a:p>
-            <a:r>
-              <a:t>Narrator: Lesson eleven. Hector calls customer service about a cracked phone screen. Ms. Lane answers. The phone call is the whole story.</a:t>
-            </a:r>
-          </a:p>
-          <a:p>
-            <a:r>
-              <a:t>Ms. Lane: Thank you for calling customer service. This is Ms. Lane. How can I help you?</a:t>
-            </a:r>
-          </a:p>
-          <a:p>
-            <a:r>
-              <a:t>Hector: Hello. I want to file a claim for a cracked screen. Waiting on hold was tiring, but I'm glad you answered.</a:t>
-            </a:r>
-          </a:p>
-          <a:p>
-            <a:r>
-              <a:t>Ms. Lane: I can help. What is your policy number?</a:t>
-            </a:r>
-          </a:p>
-          <a:p>
-            <a:r>
-              <a:t>Hector: It is four two eight. I was wondering if you could look up my claim.</a:t>
-            </a:r>
-          </a:p>
-          <a:p>
-            <a:r>
-              <a:t>Ms. Lane: The form was received. The claim is about a cracked screen. Is that right?</a:t>
-            </a:r>
-          </a:p>
-          <a:p>
-            <a:r>
-              <a:t>Hector: Yes. Filing a claim takes time, so I sent a photo last week.</a:t>
-            </a:r>
-          </a:p>
-          <a:p>
-            <a:r>
-              <a:t>Ms. Lane: The photo was attached. Sending a photo helps, but we still need the estimate.</a:t>
-            </a:r>
-          </a:p>
-          <a:p>
-            <a:r>
-              <a:t>Hector: I was wondering if you could tell me the reference number. I want to send the estimate today.</a:t>
-            </a:r>
-          </a:p>
-          <a:p>
-            <a:r>
-              <a:t>Ms. Lane: The reference number is seven one. Please send the estimate as an attachment.</a:t>
-            </a:r>
-          </a:p>
-          <a:p>
-            <a:r>
-              <a:t>Hector: Would you mind saying that number again? I want to write it on the claim form.</a:t>
-            </a:r>
-          </a:p>
-          <a:p>
-            <a:r>
-              <a:t>Ms. Lane: Of course. Seven one. You have to include the policy number on the estimate.</a:t>
-            </a:r>
-          </a:p>
-          <a:p>
-            <a:r>
-              <a:t>Hector: Sending the estimate is my next step. I don't want to stay on hold again.</a:t>
-            </a:r>
-          </a:p>
-          <a:p>
-            <a:r>
-              <a:t>Ms. Lane: You don't have to wait on hold. You can send the attachment with the reference number.</a:t>
-            </a:r>
-          </a:p>
-          <a:p>
-            <a:r>
-              <a:t>Hector: This is not a water stain. A water stain can be a claim too, but that stain is already dry. Nobody was hurt.</a:t>
-            </a:r>
-          </a:p>
-          <a:p>
-            <a:r>
-              <a:t>Ms. Lane: This file is only the cracked screen. The home is safe. When the estimate arrives, we can look for a resolution.</a:t>
-            </a:r>
-          </a:p>
-          <a:p>
-            <a:r>
-              <a:t>Hector: I'm going to send it today. Thank you for your help.</a:t>
-            </a:r>
-          </a:p>
-          <a:p>
-            <a:r>
-              <a:t>Ms. Lane: Thank you, Hector. A clear photo and a clear estimate are enough for this practice file.</a:t>
-            </a:r>
-          </a:p>
-          <a:p>
-            <a:r>
-              <a:t>Narrator: That's the end of the listening.</a:t>
+              <a:t>gonna and wanna are short forms. This listening uses the full forms. Say each line two times.</a:t>
+            </a:r>
+          </a:p>
+          <a:p>
+            <a:r>
+              <a:t>Lesson plan: Step 3: Hear it, say it.</a:t>
             </a:r>
           </a:p>
         </p:txBody>
@@ -1541,7 +1461,7 @@
 </p:notes>
 </file>
 
-<file path=ppt/notesSlides/notesSlide23.xml><?xml version="1.0" encoding="utf-8"?>
+<file path=ppt/notesSlides/notesSlide39.xml><?xml version="1.0" encoding="utf-8"?>
 <p:notes xmlns:a="http://schemas.openxmlformats.org/drawingml/2006/main" xmlns:p="http://schemas.openxmlformats.org/presentationml/2006/main" xmlns:r="http://schemas.openxmlformats.org/officeDocument/2006/relationships">
   <p:cSld>
     <p:spTree>
@@ -1586,32 +1506,17 @@
           <a:lstStyle/>
           <a:p>
             <a:r>
-              <a:t>The answers are hidden. Ask, then click.</a:t>
-            </a:r>
-          </a:p>
-          <a:p>
-            <a:r>
-              <a:t>1. One.</a:t>
-            </a:r>
-          </a:p>
-          <a:p>
-            <a:r>
-              <a:t>2. *is*</a:t>
-            </a:r>
-          </a:p>
-          <a:p>
-            <a:r>
-              <a:t>3. It was attached.</a:t>
-            </a:r>
-          </a:p>
-          <a:p>
-            <a:r>
-              <a:t>Lesson plan: Step 2: Check the Meaning.</a:t>
-            </a:r>
-          </a:p>
-          <a:p>
-            <a:r>
-              <a:t>Pictures: Twemoji graphics by Twitter, Inc. and other contributors (https://github.com/jdecked/twemoji), CC BY 4.0 (https://creativecommons.org/licenses/by/4.0/); resized and combined, with signs and labels (images/CREDITS.md).</a:t>
+              <a:t>Grammar Box 1: a gerund is the subject. Each click shows the answer side.</a:t>
+            </a:r>
+          </a:p>
+          <a:p>
+            <a:r>
+              <a:t>Lesson plan: Step 4; Grammar Box 1.</a:t>
+            </a:r>
+          </a:p>
+          <a:p>
+            <a:r>
+              <a:t>Picture: Twemoji graphics by Twitter, Inc. and other contributors (https://github.com/jdecked/twemoji), CC BY 4.0 (https://creativecommons.org/licenses/by/4.0/); resized and combined, with signs and labels (images/CREDITS.md).</a:t>
             </a:r>
           </a:p>
         </p:txBody>
@@ -1636,7 +1541,7 @@
 </p:notes>
 </file>
 
-<file path=ppt/notesSlides/notesSlide24.xml><?xml version="1.0" encoding="utf-8"?>
+<file path=ppt/notesSlides/notesSlide40.xml><?xml version="1.0" encoding="utf-8"?>
 <p:notes xmlns:a="http://schemas.openxmlformats.org/drawingml/2006/main" xmlns:p="http://schemas.openxmlformats.org/presentationml/2006/main" xmlns:r="http://schemas.openxmlformats.org/officeDocument/2006/relationships">
   <p:cSld>
     <p:spTree>
@@ -1681,17 +1586,17 @@
           <a:lstStyle/>
           <a:p>
             <a:r>
-              <a:t>A points to a picture. B names it and uses it in one sentence. Then switch.</a:t>
-            </a:r>
-          </a:p>
-          <a:p>
-            <a:r>
-              <a:t>Lesson plan: Step 2; New Words page; Partner game.</a:t>
-            </a:r>
-          </a:p>
-          <a:p>
-            <a:r>
-              <a:t>Pictures: Twemoji graphics by Twitter, Inc. and other contributors (https://github.com/jdecked/twemoji), CC BY 4.0 (https://creativecommons.org/licenses/by/4.0/); resized and combined, with signs and labels (images/CREDITS.md).</a:t>
+              <a:t>Grammar Box 2: a soft request. Each click shows the answer side.</a:t>
+            </a:r>
+          </a:p>
+          <a:p>
+            <a:r>
+              <a:t>Lesson plan: Step 4; Grammar Box 2.</a:t>
+            </a:r>
+          </a:p>
+          <a:p>
+            <a:r>
+              <a:t>Picture: Twemoji graphics by Twitter, Inc. and other contributors (https://github.com/jdecked/twemoji), CC BY 4.0 (https://creativecommons.org/licenses/by/4.0/); resized and combined, with signs and labels (images/CREDITS.md).</a:t>
             </a:r>
           </a:p>
         </p:txBody>
@@ -1716,7 +1621,7 @@
 </p:notes>
 </file>
 
-<file path=ppt/notesSlides/notesSlide25.xml><?xml version="1.0" encoding="utf-8"?>
+<file path=ppt/notesSlides/notesSlide41.xml><?xml version="1.0" encoding="utf-8"?>
 <p:notes xmlns:a="http://schemas.openxmlformats.org/drawingml/2006/main" xmlns:p="http://schemas.openxmlformats.org/presentationml/2006/main" xmlns:r="http://schemas.openxmlformats.org/officeDocument/2006/relationships">
   <p:cSld>
     <p:spTree>
@@ -1761,22 +1666,17 @@
           <a:lstStyle/>
           <a:p>
             <a:r>
-              <a:t>Step 2 · 6:06–6:12 · New Words.</a:t>
-            </a:r>
-          </a:p>
-          <a:p>
-            <a:r>
-              <a:t>Point to each picture. Learners repeat. ★ = most important.</a:t>
-            </a:r>
-          </a:p>
-          <a:p>
-            <a:r>
-              <a:t>Lesson plan: Step 2; New Words page.</a:t>
-            </a:r>
-          </a:p>
-          <a:p>
-            <a:r>
-              <a:t>Pictures: Twemoji graphics by Twitter, Inc. and other contributors (https://github.com/jdecked/twemoji), CC BY 4.0 (https://creativecommons.org/licenses/by/4.0/); resized and combined, with signs and labels (images/CREDITS.md).</a:t>
+              <a:t>Grammar Box 3: what was sent. Each click shows the answer side.</a:t>
+            </a:r>
+          </a:p>
+          <a:p>
+            <a:r>
+              <a:t>Lesson plan: Step 4; Grammar Box 3.</a:t>
+            </a:r>
+          </a:p>
+          <a:p>
+            <a:r>
+              <a:t>Picture: Twemoji graphics by Twitter, Inc. and other contributors (https://github.com/jdecked/twemoji), CC BY 4.0 (https://creativecommons.org/licenses/by/4.0/); resized and combined, with signs and labels (images/CREDITS.md).</a:t>
             </a:r>
           </a:p>
         </p:txBody>
@@ -1801,7 +1701,7 @@
 </p:notes>
 </file>
 
-<file path=ppt/notesSlides/notesSlide27.xml><?xml version="1.0" encoding="utf-8"?>
+<file path=ppt/notesSlides/notesSlide42.xml><?xml version="1.0" encoding="utf-8"?>
 <p:notes xmlns:a="http://schemas.openxmlformats.org/drawingml/2006/main" xmlns:p="http://schemas.openxmlformats.org/presentationml/2006/main" xmlns:r="http://schemas.openxmlformats.org/officeDocument/2006/relationships">
   <p:cSld>
     <p:spTree>
@@ -1846,22 +1746,12 @@
           <a:lstStyle/>
           <a:p>
             <a:r>
-              <a:t>Welcome learners as they arrive.</a:t>
-            </a:r>
-          </a:p>
-          <a:p>
-            <a:r>
-              <a:t>Read the three lines under Today you will.</a:t>
-            </a:r>
-          </a:p>
-          <a:p>
-            <a:r>
-              <a:t>It is not insurance advice.</a:t>
-            </a:r>
-          </a:p>
-          <a:p>
-            <a:r>
-              <a:t>Lesson plan: Topic; At a glance: Objectives.</a:t>
+              <a:t>Grammar Box 4: have to. Each click shows the answer side.</a:t>
+            </a:r>
+          </a:p>
+          <a:p>
+            <a:r>
+              <a:t>Lesson plan: Step 4; Grammar Box 4.</a:t>
             </a:r>
           </a:p>
           <a:p>
@@ -1891,7 +1781,7 @@
 </p:notes>
 </file>
 
-<file path=ppt/notesSlides/notesSlide28.xml><?xml version="1.0" encoding="utf-8"?>
+<file path=ppt/notesSlides/notesSlide43.xml><?xml version="1.0" encoding="utf-8"?>
 <p:notes xmlns:a="http://schemas.openxmlformats.org/drawingml/2006/main" xmlns:p="http://schemas.openxmlformats.org/presentationml/2006/main" xmlns:r="http://schemas.openxmlformats.org/officeDocument/2006/relationships">
   <p:cSld>
     <p:spTree>
@@ -1936,12 +1826,12 @@
           <a:lstStyle/>
           <a:p>
             <a:r>
-              <a:t>Read each goal slowly. Learners repeat.</a:t>
-            </a:r>
-          </a:p>
-          <a:p>
-            <a:r>
-              <a:t>Lesson plan: At a glance: Objectives.</a:t>
+              <a:t>Click to show each answer: 1 is • 2 attached • 3 takes • 4 could • 5 received • 6 helps</a:t>
+            </a:r>
+          </a:p>
+          <a:p>
+            <a:r>
+              <a:t>Lesson plan: Step 4; Grammar Practice A; Answer key.</a:t>
             </a:r>
           </a:p>
         </p:txBody>
@@ -1966,7 +1856,7 @@
 </p:notes>
 </file>
 
-<file path=ppt/notesSlides/notesSlide29.xml><?xml version="1.0" encoding="utf-8"?>
+<file path=ppt/notesSlides/notesSlide44.xml><?xml version="1.0" encoding="utf-8"?>
 <p:notes xmlns:a="http://schemas.openxmlformats.org/drawingml/2006/main" xmlns:p="http://schemas.openxmlformats.org/presentationml/2006/main" xmlns:r="http://schemas.openxmlformats.org/officeDocument/2006/relationships">
   <p:cSld>
     <p:spTree>
@@ -2011,22 +1901,12 @@
           <a:lstStyle/>
           <a:p>
             <a:r>
-              <a:t>Step 1 · 6:00–6:06 · Opening Talk.</a:t>
-            </a:r>
-          </a:p>
-          <a:p>
-            <a:r>
-              <a:t>Work with a partner.</a:t>
-            </a:r>
-          </a:p>
-          <a:p>
-            <a:r>
-              <a:t>Lesson plan: Step 1; Opening Talk page.</a:t>
-            </a:r>
-          </a:p>
-          <a:p>
-            <a:r>
-              <a:t>Picture: Twemoji graphics by Twitter, Inc. and other contributors (https://github.com/jdecked/twemoji), CC BY 4.0 (https://creativecommons.org/licenses/by/4.0/); resized and combined, with signs and labels (images/CREDITS.md).</a:t>
+              <a:t>Click to circle each answer: 1 is • 2 you could • 3 attached • 4 Filing • 5 have to • 6 helps</a:t>
+            </a:r>
+          </a:p>
+          <a:p>
+            <a:r>
+              <a:t>Lesson plan: Step 4; Grammar Practice B; Answer key.</a:t>
             </a:r>
           </a:p>
         </p:txBody>
@@ -2051,7 +1931,7 @@
 </p:notes>
 </file>
 
-<file path=ppt/notesSlides/notesSlide3.xml><?xml version="1.0" encoding="utf-8"?>
+<file path=ppt/notesSlides/notesSlide45.xml><?xml version="1.0" encoding="utf-8"?>
 <p:notes xmlns:a="http://schemas.openxmlformats.org/drawingml/2006/main" xmlns:p="http://schemas.openxmlformats.org/presentationml/2006/main" xmlns:r="http://schemas.openxmlformats.org/officeDocument/2006/relationships">
   <p:cSld>
     <p:spTree>
@@ -2096,17 +1976,17 @@
           <a:lstStyle/>
           <a:p>
             <a:r>
-              <a:t>Step 6 · 7:18–7:25 · Read &amp; Write.</a:t>
-            </a:r>
-          </a:p>
-          <a:p>
-            <a:r>
-              <a:t>Click to show each answer: 1 A cracked phone screen • 2 The photo • 3 The estimate • 4 Seven one • 5 Four two eight</a:t>
-            </a:r>
-          </a:p>
-          <a:p>
-            <a:r>
-              <a:t>Lesson plan: Step 6; Read &amp; Write page; Answer key.</a:t>
+              <a:t>Read Don't say, then Say. Learners try first. Then click.</a:t>
+            </a:r>
+          </a:p>
+          <a:p>
+            <a:r>
+              <a:t>Lesson plan: Grammar: Common mistakes.</a:t>
+            </a:r>
+          </a:p>
+          <a:p>
+            <a:r>
+              <a:t>Picture: Twemoji graphics by Twitter, Inc. and other contributors (https://github.com/jdecked/twemoji), CC BY 4.0 (https://creativecommons.org/licenses/by/4.0/); resized and combined, with signs and labels (images/CREDITS.md).</a:t>
             </a:r>
           </a:p>
         </p:txBody>
@@ -2131,7 +2011,7 @@
 </p:notes>
 </file>
 
-<file path=ppt/notesSlides/notesSlide30.xml><?xml version="1.0" encoding="utf-8"?>
+<file path=ppt/notesSlides/notesSlide46.xml><?xml version="1.0" encoding="utf-8"?>
 <p:notes xmlns:a="http://schemas.openxmlformats.org/drawingml/2006/main" xmlns:p="http://schemas.openxmlformats.org/presentationml/2006/main" xmlns:r="http://schemas.openxmlformats.org/officeDocument/2006/relationships">
   <p:cSld>
     <p:spTree>
@@ -2176,17 +2056,22 @@
           <a:lstStyle/>
           <a:p>
             <a:r>
-              <a:t>Each click shows the next card.</a:t>
-            </a:r>
-          </a:p>
-          <a:p>
-            <a:r>
-              <a:t>A asks. B answers. Then switch.</a:t>
-            </a:r>
-          </a:p>
-          <a:p>
-            <a:r>
-              <a:t>Lesson plan: Step 1; Opening Talk page.</a:t>
+              <a:t>A says: "Waiting on hold." B says: "Waiting on hold is tiring." Then switch. Use filing and sending too. ---</a:t>
+            </a:r>
+          </a:p>
+          <a:p>
+            <a:r>
+              <a:t>Break · 6:45–7:00.</a:t>
+            </a:r>
+          </a:p>
+          <a:p>
+            <a:r>
+              <a:t>Lesson plan: Step 4: Pair check.</a:t>
+            </a:r>
+          </a:p>
+          <a:p>
+            <a:r>
+              <a:t>Picture: Twemoji graphics by Twitter, Inc. and other contributors (https://github.com/jdecked/twemoji), CC BY 4.0 (https://creativecommons.org/licenses/by/4.0/); resized and combined, with signs and labels (images/CREDITS.md).</a:t>
             </a:r>
           </a:p>
         </p:txBody>
@@ -2211,7 +2096,7 @@
 </p:notes>
 </file>
 
-<file path=ppt/notesSlides/notesSlide4.xml><?xml version="1.0" encoding="utf-8"?>
+<file path=ppt/notesSlides/notesSlide47.xml><?xml version="1.0" encoding="utf-8"?>
 <p:notes xmlns:a="http://schemas.openxmlformats.org/drawingml/2006/main" xmlns:p="http://schemas.openxmlformats.org/presentationml/2006/main" xmlns:r="http://schemas.openxmlformats.org/officeDocument/2006/relationships">
   <p:cSld>
     <p:spTree>
@@ -2256,7 +2141,7 @@
           <a:lstStyle/>
           <a:p>
             <a:r>
-              <a:t>Round 2.</a:t>
+              <a:t>Round 1.</a:t>
             </a:r>
           </a:p>
           <a:p>
@@ -2291,7 +2176,7 @@
 </p:notes>
 </file>
 
-<file path=ppt/notesSlides/notesSlide5.xml><?xml version="1.0" encoding="utf-8"?>
+<file path=ppt/notesSlides/notesSlide48.xml><?xml version="1.0" encoding="utf-8"?>
 <p:notes xmlns:a="http://schemas.openxmlformats.org/drawingml/2006/main" xmlns:p="http://schemas.openxmlformats.org/presentationml/2006/main" xmlns:r="http://schemas.openxmlformats.org/officeDocument/2006/relationships">
   <p:cSld>
     <p:spTree>
@@ -2336,7 +2221,7 @@
           <a:lstStyle/>
           <a:p>
             <a:r>
-              <a:t>Round 1.</a:t>
+              <a:t>Round 2.</a:t>
             </a:r>
           </a:p>
           <a:p>
@@ -2371,7 +2256,7 @@
 </p:notes>
 </file>
 
-<file path=ppt/notesSlides/notesSlide51.xml><?xml version="1.0" encoding="utf-8"?>
+<file path=ppt/notesSlides/notesSlide49.xml><?xml version="1.0" encoding="utf-8"?>
 <p:notes xmlns:a="http://schemas.openxmlformats.org/drawingml/2006/main" xmlns:p="http://schemas.openxmlformats.org/presentationml/2006/main" xmlns:r="http://schemas.openxmlformats.org/officeDocument/2006/relationships">
   <p:cSld>
     <p:spTree>
@@ -2416,22 +2301,17 @@
           <a:lstStyle/>
           <a:p>
             <a:r>
-              <a:t>Read the three Now you can lines.</a:t>
-            </a:r>
-          </a:p>
-          <a:p>
-            <a:r>
-              <a:t>Homework is about 20–25 minutes. Bring it next week.</a:t>
-            </a:r>
-          </a:p>
-          <a:p>
-            <a:r>
-              <a:t>Lesson plan: At a glance: Objectives; Step 7.</a:t>
-            </a:r>
-          </a:p>
-          <a:p>
-            <a:r>
-              <a:t>Picture: Twemoji graphics by Twitter, Inc. and other contributors (https://github.com/jdecked/twemoji), CC BY 4.0 (https://creativecommons.org/licenses/by/4.0/); resized and combined, with signs and labels (images/CREDITS.md).</a:t>
+              <a:t>Step 6 · 7:18–7:25 · Read &amp; Write.</a:t>
+            </a:r>
+          </a:p>
+          <a:p>
+            <a:r>
+              <a:t>Click to show each answer: 1 A cracked phone screen • 2 The photo • 3 The estimate • 4 Seven one • 5 Four two eight</a:t>
+            </a:r>
+          </a:p>
+          <a:p>
+            <a:r>
+              <a:t>Lesson plan: Step 6; Read &amp; Write page; Answer key.</a:t>
             </a:r>
           </a:p>
         </p:txBody>
@@ -2456,7 +2336,7 @@
 </p:notes>
 </file>
 
-<file path=ppt/notesSlides/notesSlide6.xml><?xml version="1.0" encoding="utf-8"?>
+<file path=ppt/notesSlides/notesSlide50.xml><?xml version="1.0" encoding="utf-8"?>
 <p:notes xmlns:a="http://schemas.openxmlformats.org/drawingml/2006/main" xmlns:p="http://schemas.openxmlformats.org/presentationml/2006/main" xmlns:r="http://schemas.openxmlformats.org/officeDocument/2006/relationships">
   <p:cSld>
     <p:spTree>
@@ -2501,17 +2381,17 @@
           <a:lstStyle/>
           <a:p>
             <a:r>
-              <a:t>A says: "Waiting on hold." B says: "Waiting on hold is tiring." Then switch. Use filing and sending too. ---</a:t>
-            </a:r>
-          </a:p>
-          <a:p>
-            <a:r>
-              <a:t>Break · 6:45–7:00.</a:t>
-            </a:r>
-          </a:p>
-          <a:p>
-            <a:r>
-              <a:t>Lesson plan: Step 4: Pair check.</a:t>
+              <a:t>Step 7 · 7:25–7:30 · Exit ticket and homework. Never skip the exit ticket.</a:t>
+            </a:r>
+          </a:p>
+          <a:p>
+            <a:r>
+              <a:t>Start a claim letter.</a:t>
+            </a:r>
+          </a:p>
+          <a:p>
+            <a:r>
+              <a:t>Lesson plan: Step 7; Exit Ticket page; Homework page.</a:t>
             </a:r>
           </a:p>
           <a:p>
@@ -2541,7 +2421,7 @@
 </p:notes>
 </file>
 
-<file path=ppt/notesSlides/notesSlide7.xml><?xml version="1.0" encoding="utf-8"?>
+<file path=ppt/notesSlides/notesSlide52.xml><?xml version="1.0" encoding="utf-8"?>
 <p:notes xmlns:a="http://schemas.openxmlformats.org/drawingml/2006/main" xmlns:p="http://schemas.openxmlformats.org/presentationml/2006/main" xmlns:r="http://schemas.openxmlformats.org/officeDocument/2006/relationships">
   <p:cSld>
     <p:spTree>
@@ -2586,17 +2466,27 @@
           <a:lstStyle/>
           <a:p>
             <a:r>
-              <a:t>Read Don't say, then Say. Learners try first. Then click.</a:t>
-            </a:r>
-          </a:p>
-          <a:p>
-            <a:r>
-              <a:t>Lesson plan: Grammar: Common mistakes.</a:t>
-            </a:r>
-          </a:p>
-          <a:p>
-            <a:r>
-              <a:t>Picture: Twemoji graphics by Twitter, Inc. and other contributors (https://github.com/jdecked/twemoji), CC BY 4.0 (https://creativecommons.org/licenses/by/4.0/); resized and combined, with signs and labels (images/CREDITS.md).</a:t>
+              <a:t>Credits. You don't need to read this slide in class.</a:t>
+            </a:r>
+          </a:p>
+          <a:p>
+            <a:r>
+              <a:t>Pictures: Twemoji graphics by Twitter, Inc. and other contributors, CC BY 4.0; the file-by-file list is in images/CREDITS.md.</a:t>
+            </a:r>
+          </a:p>
+          <a:p>
+            <a:r>
+              <a:t>Audio: synthetic voices, computer-generated (Chatterbox TTS cloned from Kokoro-82M reference clips). No recordings of real people. The names and the story are invented.</a:t>
+            </a:r>
+          </a:p>
+          <a:p>
+            <a:r>
+              <a:t>Course materials: © 2026 the authors, licensed under CC BY-NC-SA 4.0 (https://creativecommons.org/licenses/by-nc-sa/4.0/).</a:t>
+            </a:r>
+          </a:p>
+          <a:p>
+            <a:r>
+              <a:t>Lesson plan: Picture Credits. Picture list: images/CREDITS.md.</a:t>
             </a:r>
           </a:p>
         </p:txBody>
@@ -2621,7 +2511,7 @@
 </p:notes>
 </file>
 
-<file path=ppt/notesSlides/notesSlide9.xml><?xml version="1.0" encoding="utf-8"?>
+<file path=ppt/notesSlides/notesSlide8.xml><?xml version="1.0" encoding="utf-8"?>
 <p:notes xmlns:a="http://schemas.openxmlformats.org/drawingml/2006/main" xmlns:p="http://schemas.openxmlformats.org/presentationml/2006/main" xmlns:r="http://schemas.openxmlformats.org/officeDocument/2006/relationships">
   <p:cSld>
     <p:spTree>
@@ -2666,12 +2556,22 @@
           <a:lstStyle/>
           <a:p>
             <a:r>
-              <a:t>Click to circle each answer: 1 is • 2 you could • 3 attached • 4 Filing • 5 have to • 6 helps</a:t>
-            </a:r>
-          </a:p>
-          <a:p>
-            <a:r>
-              <a:t>Lesson plan: Step 4; Grammar Practice B; Answer key.</a:t>
+              <a:t>Read the three Now you can lines.</a:t>
+            </a:r>
+          </a:p>
+          <a:p>
+            <a:r>
+              <a:t>Homework is about 20–25 minutes. Bring it next week.</a:t>
+            </a:r>
+          </a:p>
+          <a:p>
+            <a:r>
+              <a:t>Lesson plan: At a glance: Objectives; Step 7.</a:t>
+            </a:r>
+          </a:p>
+          <a:p>
+            <a:r>
+              <a:t>Picture: Twemoji graphics by Twitter, Inc. and other contributors (https://github.com/jdecked/twemoji), CC BY 4.0 (https://creativecommons.org/licenses/by/4.0/); resized and combined, with signs and labels (images/CREDITS.md).</a:t>
             </a:r>
           </a:p>
         </p:txBody>
@@ -9361,7 +9261,7 @@
             <a:r>
               <a:rPr lang="en-US" sz="1800" dirty="0" b="1">
                 <a:solidFill>
-                  <a:srgbClr val="1B2236"/>
+                  <a:srgbClr val="5B3FC4"/>
                 </a:solidFill>
                 <a:latin typeface="Lexend Deca" pitchFamily="34" charset="0"/>
                 <a:ea typeface="Lexend Deca" pitchFamily="34" charset="-122"/>
@@ -10463,7 +10363,7 @@
                 <a:ea typeface="Lexend Deca" pitchFamily="34" charset="-122"/>
                 <a:cs typeface="Lexend Deca" pitchFamily="34" charset="-120"/>
               </a:rPr>
-              <a:t>Audio (about 2:30): coming soon.</a:t>
+              <a:t>Audio: about 2:02. It plays once.</a:t>
             </a:r>
             <a:endParaRPr lang="en-US" sz="2200" dirty="0"/>
           </a:p>
@@ -25800,9 +25700,9 @@
               <a:buNone/>
             </a:pPr>
             <a:r>
-              <a:rPr lang="en-US" sz="1600" dirty="0" b="0">
-                <a:solidFill>
-                  <a:srgbClr val="5B3FC4"/>
+              <a:rPr lang="en-US" sz="1600" dirty="0" b="1">
+                <a:solidFill>
+                  <a:srgbClr val="1B2236"/>
                 </a:solidFill>
                 <a:latin typeface="Lexend Deca" pitchFamily="34" charset="0"/>
                 <a:ea typeface="Lexend Deca" pitchFamily="34" charset="-122"/>
@@ -25810,7 +25710,7 @@
               </a:rPr>
               <a:t>writes full sentences.</a:t>
             </a:r>
-            <a:endParaRPr lang="en-US" sz="1600" dirty="0" b="0"/>
+            <a:endParaRPr lang="en-US" sz="1600" dirty="0" b="1"/>
           </a:p>
         </p:txBody>
       </p:sp>
@@ -29029,7 +28929,7 @@
                 <a:ea typeface="Lexend Deca" pitchFamily="34" charset="-122"/>
                 <a:cs typeface="Lexend Deca" pitchFamily="34" charset="-120"/>
               </a:rPr>
-              <a:t>Audio (coming soon): synthetic voices made with Chatterbox TTS (MIT License), cloned from short synthetic reference clips made with Kokoro-82M (Apache License 2.0). No recordings of real people. Each file will carry an inaudible Perth watermark marking it as AI-generated. Font: Lexend Deca (OFL 1.1).</a:t>
+              <a:t>Audio: synthetic voices made with Chatterbox TTS (MIT License), cloned from short synthetic reference clips made with Kokoro-82M (Apache License 2.0). No recordings of real people were used. Each file carries an inaudible Perth watermark marking it as AI-generated. Font: Lexend Deca (OFL 1.1).</a:t>
             </a:r>
             <a:endParaRPr lang="en-US" sz="1350" dirty="0" b="0"/>
           </a:p>

</xml_diff>